<commit_message>
Regenerate frankfurt-talk.pptx with closing 'Connect' slide
Picks up the new slide 21 added to talk-deck.md: a 'Connect'
lead-layout closer carrying Tom's contact line and The Gathering
URL. Engine reports 21 clones now (was 20); page chrome renumbered
to NN / 21.
</commit_message>
<xml_diff>
--- a/pptx/presentations/frankfurt-talk.pptx
+++ b/pptx/presentations/frankfurt-talk.pptx
@@ -25,6 +25,7 @@
     <p:sldId id="277" r:id="rId28"/>
     <p:sldId id="278" r:id="rId29"/>
     <p:sldId id="279" r:id="rId30"/>
+    <p:sldId id="280" r:id="rId31"/>
   </p:sldIdLst>
   <p:sldSz cx="12188952" cy="6858000" type="screen4x3"/>
   <p:notesSz cx="6858000" cy="9144000"/>
@@ -3137,7 +3138,7 @@
                 </a:solidFill>
                 <a:latin typeface="JetBrains Mono"/>
               </a:rPr>
-              <a:t>06 / 20</a:t>
+              <a:t>06 / 21</a:t>
             </a:r>
           </a:p>
         </p:txBody>
@@ -3366,7 +3367,7 @@
                 </a:solidFill>
                 <a:latin typeface="JetBrains Mono"/>
               </a:rPr>
-              <a:t>07 / 20</a:t>
+              <a:t>07 / 21</a:t>
             </a:r>
           </a:p>
         </p:txBody>
@@ -3594,7 +3595,7 @@
                 </a:solidFill>
                 <a:latin typeface="JetBrains Mono"/>
               </a:rPr>
-              <a:t>08 / 20</a:t>
+              <a:t>08 / 21</a:t>
             </a:r>
           </a:p>
         </p:txBody>
@@ -3826,7 +3827,7 @@
                 </a:solidFill>
                 <a:latin typeface="JetBrains Mono"/>
               </a:rPr>
-              <a:t>09 / 20</a:t>
+              <a:t>09 / 21</a:t>
             </a:r>
           </a:p>
         </p:txBody>
@@ -4057,7 +4058,7 @@
                 </a:solidFill>
                 <a:latin typeface="JetBrains Mono"/>
               </a:rPr>
-              <a:t>10 / 20</a:t>
+              <a:t>10 / 21</a:t>
             </a:r>
           </a:p>
         </p:txBody>
@@ -4288,7 +4289,7 @@
                 </a:solidFill>
                 <a:latin typeface="JetBrains Mono"/>
               </a:rPr>
-              <a:t>11 / 20</a:t>
+              <a:t>11 / 21</a:t>
             </a:r>
           </a:p>
         </p:txBody>
@@ -4523,7 +4524,7 @@
                 </a:solidFill>
                 <a:latin typeface="JetBrains Mono"/>
               </a:rPr>
-              <a:t>12 / 20</a:t>
+              <a:t>12 / 21</a:t>
             </a:r>
           </a:p>
         </p:txBody>
@@ -4755,7 +4756,7 @@
                 </a:solidFill>
                 <a:latin typeface="JetBrains Mono"/>
               </a:rPr>
-              <a:t>13 / 20</a:t>
+              <a:t>13 / 21</a:t>
             </a:r>
           </a:p>
         </p:txBody>
@@ -4987,7 +4988,7 @@
                 </a:solidFill>
                 <a:latin typeface="JetBrains Mono"/>
               </a:rPr>
-              <a:t>14 / 20</a:t>
+              <a:t>14 / 21</a:t>
             </a:r>
           </a:p>
         </p:txBody>
@@ -5215,7 +5216,7 @@
                 </a:solidFill>
                 <a:latin typeface="JetBrains Mono"/>
               </a:rPr>
-              <a:t>15 / 20</a:t>
+              <a:t>15 / 21</a:t>
             </a:r>
           </a:p>
         </p:txBody>
@@ -5445,7 +5446,7 @@
                 </a:solidFill>
                 <a:latin typeface="JetBrains Mono"/>
               </a:rPr>
-              <a:t>16 / 20</a:t>
+              <a:t>16 / 21</a:t>
             </a:r>
           </a:p>
         </p:txBody>
@@ -5679,7 +5680,7 @@
                 </a:solidFill>
                 <a:latin typeface="JetBrains Mono"/>
               </a:rPr>
-              <a:t>17 / 20</a:t>
+              <a:t>17 / 21</a:t>
             </a:r>
           </a:p>
         </p:txBody>
@@ -5910,7 +5911,7 @@
                 </a:solidFill>
                 <a:latin typeface="JetBrains Mono"/>
               </a:rPr>
-              <a:t>18 / 20</a:t>
+              <a:t>18 / 21</a:t>
             </a:r>
           </a:p>
         </p:txBody>
@@ -6140,7 +6141,7 @@
                 </a:solidFill>
                 <a:latin typeface="JetBrains Mono"/>
               </a:rPr>
-              <a:t>19 / 20</a:t>
+              <a:t>19 / 21</a:t>
             </a:r>
           </a:p>
         </p:txBody>
@@ -6333,7 +6334,7 @@
                 </a:solidFill>
                 <a:latin typeface="JetBrains Mono"/>
               </a:rPr>
-              <a:t>20 / 20</a:t>
+              <a:t>20 / 21</a:t>
             </a:r>
           </a:p>
         </p:txBody>
@@ -6404,6 +6405,199 @@
                 <a:latin typeface="Source Serif 4"/>
               </a:rPr>
               <a:t>Is your CMS ready?</a:t>
+            </a:r>
+          </a:p>
+        </p:txBody>
+      </p:sp>
+      <p:sp>
+        <p:nvSpPr>
+          <p:cNvPr id="5" name="TextBox 4"/>
+          <p:cNvSpPr txBox="1"/>
+          <p:nvPr/>
+        </p:nvSpPr>
+        <p:spPr>
+          <a:xfrm>
+            <a:off x="548640" y="4572000"/>
+            <a:ext cx="11091672" cy="457200"/>
+          </a:xfrm>
+          <a:prstGeom prst="rect">
+            <a:avLst/>
+          </a:prstGeom>
+          <a:noFill/>
+        </p:spPr>
+        <p:txBody>
+          <a:bodyPr wrap="square" anchor="t">
+            <a:spAutoFit/>
+          </a:bodyPr>
+          <a:lstStyle/>
+          <a:p>
+            <a:pPr algn="l"/>
+            <a:r>
+              <a:rPr sz="1400" b="0" i="0">
+                <a:solidFill>
+                  <a:srgbClr val="555555"/>
+                </a:solidFill>
+                <a:latin typeface="Inter"/>
+              </a:rPr>
+              <a:t/>
+            </a:r>
+          </a:p>
+        </p:txBody>
+      </p:sp>
+      <p:sp>
+        <p:nvSpPr>
+          <p:cNvPr id="6" name="TextBox 5"/>
+          <p:cNvSpPr txBox="1"/>
+          <p:nvPr/>
+        </p:nvSpPr>
+        <p:spPr>
+          <a:xfrm>
+            <a:off x="548640" y="6400800"/>
+            <a:ext cx="11091672" cy="365760"/>
+          </a:xfrm>
+          <a:prstGeom prst="rect">
+            <a:avLst/>
+          </a:prstGeom>
+          <a:noFill/>
+        </p:spPr>
+        <p:txBody>
+          <a:bodyPr wrap="square" anchor="t">
+            <a:spAutoFit/>
+          </a:bodyPr>
+          <a:lstStyle/>
+          <a:p>
+            <a:pPr algn="l"/>
+            <a:r>
+              <a:rPr sz="900" b="0" i="0">
+                <a:solidFill>
+                  <a:srgbClr val="555555"/>
+                </a:solidFill>
+                <a:latin typeface="JetBrains Mono"/>
+              </a:rPr>
+              <a:t>TOM CRANSTOUN · CMS SUMMIT FRANKFURT 2026</a:t>
+            </a:r>
+          </a:p>
+        </p:txBody>
+      </p:sp>
+    </p:spTree>
+  </p:cSld>
+  <p:clrMapOvr>
+    <a:masterClrMapping/>
+  </p:clrMapOvr>
+</p:sld>
+</file>
+
+<file path=ppt/slides/slide25.xml><?xml version="1.0" encoding="utf-8"?>
+<p:sld xmlns:a="http://schemas.openxmlformats.org/drawingml/2006/main" xmlns:p="http://schemas.openxmlformats.org/presentationml/2006/main" xmlns:r="http://schemas.openxmlformats.org/officeDocument/2006/relationships">
+  <p:cSld>
+    <p:spTree>
+      <p:nvGrpSpPr>
+        <p:cNvPr id="1" name=""/>
+        <p:cNvGrpSpPr/>
+        <p:nvPr/>
+      </p:nvGrpSpPr>
+      <p:grpSpPr/>
+      <p:sp>
+        <p:nvSpPr>
+          <p:cNvPr id="2" name="TextBox 1"/>
+          <p:cNvSpPr txBox="1"/>
+          <p:nvPr/>
+        </p:nvSpPr>
+        <p:spPr>
+          <a:xfrm>
+            <a:off x="548640" y="365760"/>
+            <a:ext cx="11091672" cy="365760"/>
+          </a:xfrm>
+          <a:prstGeom prst="rect">
+            <a:avLst/>
+          </a:prstGeom>
+          <a:noFill/>
+        </p:spPr>
+        <p:txBody>
+          <a:bodyPr wrap="square" anchor="t">
+            <a:spAutoFit/>
+          </a:bodyPr>
+          <a:lstStyle/>
+          <a:p>
+            <a:pPr algn="r"/>
+            <a:r>
+              <a:rPr sz="1000" b="0" i="0">
+                <a:solidFill>
+                  <a:srgbClr val="555555"/>
+                </a:solidFill>
+                <a:latin typeface="JetBrains Mono"/>
+              </a:rPr>
+              <a:t>21 / 21</a:t>
+            </a:r>
+          </a:p>
+        </p:txBody>
+      </p:sp>
+      <p:sp>
+        <p:nvSpPr>
+          <p:cNvPr id="3" name="TextBox 2"/>
+          <p:cNvSpPr txBox="1"/>
+          <p:nvPr/>
+        </p:nvSpPr>
+        <p:spPr>
+          <a:xfrm>
+            <a:off x="548640" y="2194560"/>
+            <a:ext cx="11091672" cy="1463040"/>
+          </a:xfrm>
+          <a:prstGeom prst="rect">
+            <a:avLst/>
+          </a:prstGeom>
+          <a:noFill/>
+        </p:spPr>
+        <p:txBody>
+          <a:bodyPr wrap="square" anchor="ctr">
+            <a:spAutoFit/>
+          </a:bodyPr>
+          <a:lstStyle/>
+          <a:p>
+            <a:pPr algn="l"/>
+            <a:r>
+              <a:rPr sz="4600" b="0" i="0">
+                <a:solidFill>
+                  <a:srgbClr val="1A1A1A"/>
+                </a:solidFill>
+                <a:latin typeface="Source Serif 4"/>
+              </a:rPr>
+              <a:t>Connect</a:t>
+            </a:r>
+          </a:p>
+        </p:txBody>
+      </p:sp>
+      <p:sp>
+        <p:nvSpPr>
+          <p:cNvPr id="4" name="TextBox 3"/>
+          <p:cNvSpPr txBox="1"/>
+          <p:nvPr/>
+        </p:nvSpPr>
+        <p:spPr>
+          <a:xfrm>
+            <a:off x="548640" y="3749039"/>
+            <a:ext cx="11091672" cy="640080"/>
+          </a:xfrm>
+          <a:prstGeom prst="rect">
+            <a:avLst/>
+          </a:prstGeom>
+          <a:noFill/>
+        </p:spPr>
+        <p:txBody>
+          <a:bodyPr wrap="square" anchor="t">
+            <a:spAutoFit/>
+          </a:bodyPr>
+          <a:lstStyle/>
+          <a:p>
+            <a:pPr algn="l"/>
+            <a:r>
+              <a:rPr sz="2000" b="0" i="1">
+                <a:solidFill>
+                  <a:srgbClr val="2A2A28"/>
+                </a:solidFill>
+                <a:latin typeface="Source Serif 4"/>
+              </a:rPr>
+              <a:t>The Gathering: https://tg.community · CMS Summit Frankfurt 2026</a:t>
             </a:r>
           </a:p>
         </p:txBody>
@@ -6526,7 +6720,7 @@
                 </a:solidFill>
                 <a:latin typeface="JetBrains Mono"/>
               </a:rPr>
-              <a:t>01 / 20</a:t>
+              <a:t>01 / 21</a:t>
             </a:r>
           </a:p>
         </p:txBody>
@@ -6720,7 +6914,7 @@
                 </a:solidFill>
                 <a:latin typeface="JetBrains Mono"/>
               </a:rPr>
-              <a:t>02 / 20</a:t>
+              <a:t>02 / 21</a:t>
             </a:r>
           </a:p>
         </p:txBody>
@@ -6948,7 +7142,7 @@
                 </a:solidFill>
                 <a:latin typeface="JetBrains Mono"/>
               </a:rPr>
-              <a:t>03 / 20</a:t>
+              <a:t>03 / 21</a:t>
             </a:r>
           </a:p>
         </p:txBody>
@@ -7178,7 +7372,7 @@
                 </a:solidFill>
                 <a:latin typeface="JetBrains Mono"/>
               </a:rPr>
-              <a:t>04 / 20</a:t>
+              <a:t>04 / 21</a:t>
             </a:r>
           </a:p>
         </p:txBody>
@@ -7411,7 +7605,7 @@
                 </a:solidFill>
                 <a:latin typeface="JetBrains Mono"/>
               </a:rPr>
-              <a:t>05 / 20</a:t>
+              <a:t>05 / 21</a:t>
             </a:r>
           </a:p>
         </p:txBody>

</xml_diff>